<commit_message>
deck: refresh figures to main 255dc199 (parser 143, gates 664, census files=195 symbols=8318 edges=25147)
Re-derived from a Release build of this tree: kParserVer 129 -> 143, kCacheVersion
27 -> 28; src census (ripwire ./src) files 189 -> 195, symbols 8020 -> 8318,
edges 23968 -> 25147, ambiguous 8947 -> 9391, unresolved 1956 -> 2008, declined
7418 -> 7742; docs/COMMANDS.md samples 162 -> 163. Unchanged on re-derivation:
185 long flags, 33/8 MCP tools, 664 gates, 36 slides, rankGraphTeleport callers.
Main sha cited as 255dc199; the since-0.6.1 selection stays at a5229aca on purpose.

Co-Authored-By: Claude Opus 5.5 <noreply@anthropic.com>
</commit_message>
<xml_diff>
--- a/present/ripwire-showcase.pptx
+++ b/present/ripwire-showcase.pptx
@@ -1168,7 +1168,7 @@
             <a:r>
               <a:rPr lang="en-US" dirty="0"/>
               <a:t>SOURCES (cover)
-- "25 vendored tree-sitter grammars" — CHANGELOG.md [0.6.2], "### Added — GDScript (`.gd`), the 25th vendored grammar (parser version 108)", PR #233 ("Thanks to @sclyde."). README.md on main a5229aca: "25 vendored grammars"; third_party/deps/ holds 24 grammar projects, tree-sitter-typescript supplying two (typescript and tsx). Astro (#320) adds no grammar: it rides the TypeScript one.
+- "25 vendored tree-sitter grammars" — CHANGELOG.md [0.6.2], "### Added — GDScript (`.gd`), the 25th vendored grammar (parser version 108)", PR #233 ("Thanks to @sclyde."). README.md on main 255dc199: "25 vendored grammars"; third_party/deps/ holds 24 grammar projects, tree-sitter-typescript supplying two (typescript and tsx). Astro (#320) adds no grammar: it rides the TypeScript one.
 - Before GDScript: 24 — merged: #126 (merge commit 1ad9184a, 2026-09-11), which vendors the Kotlin grammar (PR #126 body: "vendored fwcd/tree-sitter-kotlin grammar"). Before #126 the count was 23. On main 40a1895b: README.md, "24 vendored grammars", and third_party/deps/ holds a kotlin/ directory.
 - The 23 it builds on: commit 680a0a3d,"It is 23: 22 upstream projects under third_party/deps/, with tree-sitter-typescript supplying both typescript and tsx"; PR #106's title, "Dart: a 23rd grammar …"; README.md, "23 vendored grammars".
 - The wave under "The ripgrep of AI context.": present/assets/paddle-out.png, rendered from docs/assets/paddle-out.svg (commit 680a0a3d; PR #133 moved the wave from the README hero to this deck).</a:t>
@@ -1365,7 +1365,7 @@
           <a:p>
             <a:r>
               <a:rPr lang="en-US" dirty="0"/>
-              <a:t>SOURCES (since 0.6.1). Window: after the v0.6.1 tag (2026-09-14) through main a5229aca (merge of #365, 2026-09-30): CHANGELOG.md [0.6.2] to [0.6.5], and [Unreleased] for what main carries into the next release.
+              <a:t>SOURCES (since 0.6.1). Window: after the v0.6.1 tag (2026-09-14) through main a5229aca (merge of #365, 2026-09-30), the point the rows were chosen at: CHANGELOG.md [0.6.2] to [0.6.5], and [Unreleased] for what main carries into the next release. Every row's figure was re-checked on main 255dc199 (train 25, #372); that train's own entries are not added, so the slide keeps its a5229aca selection on purpose.
 LEFT OUT, DELIBERATELY: skill scanning (not a central feature of the tool), any head-to-head figure (none re-measured), and per-verb byte counts.
 WHERE AND HOW IT RUNS
 - Windows x64: CHANGELOG [0.6.2] '### Added — native Windows x64 (clang-cl, MSVC ABI), behind src/infra/os.h — thanks to @lennix1337 (#44)' and '### Added — Microsoft's cl.exe builds the tree, so both Windows front ends compile and both gate'; CHANGELOG [0.6.3] '### Added — a Windows x64 release asset (preview)'. The caveat is README.md's platform row: the gate suite does not run on Windows, and ASan is compiled there but never executed.
@@ -1384,7 +1384,7 @@
 - placeholder: CHANGELOG [Unreleased] '### Added — --quality-delta placeholder kind (the eleventh): stubs and TODOs a change adds' (merge f6d6cf05): 'Every row is origin="new-symbol" and never gates'.
 - --impact depth: CHANGELOG [Unreleased] '### Changed — --impact lists the blast radius nearest first, with its hop depth' (merge 83f30561): rows run by hop depth first, the order is applied before the window cuts, and by_depth= counts reaches= per depth. Gate: test/impactdepthcheck.sh.
 - --mcp-tools: CHANGELOG [Unreleased] '### Added — --mcp-tools=LIST: the MCP server can list a subset of its tools' (merge 89f6beb6). The core profile is explore, batch, from_trace, impact, uses, fetch_body, edit_check and quality_delta (8); 'With no flag, or --mcp-tools=full, every byte the server sends is unchanged.'
-FOOTER: CHANGELOG [Unreleased] '### Changed — the versions this release moves, stated once': kParserVer 124 → 129, kCacheVersion 25 → 27; 'Every ingest cache written by an earlier build is refused and re-indexed once'. src/ingest_cache.h on main a5229aca: kParserVer = 129, kCacheVersion = 27.</a:t>
+FOOTER: CHANGELOG [Unreleased] '### Changed — the versions this release moves, stated once': kParserVer 124 → 143, kCacheVersion 25 → 28; 'Every ingest cache written by an earlier build is refused and re-indexed once'. src/ingest_cache.h on main 255dc199: kParserVer = 143, kCacheVersion = 28.</a:t>
             </a:r>
             <a:endParaRPr lang="en-US" dirty="0"/>
           </a:p>
@@ -2687,9 +2687,9 @@
             <a:r>
               <a:rPr lang="en-US" dirty="0"/>
               <a:t>SOURCES (the tripwire)
-- The src/ census is re-derived, not remembered: `ripwire ./src` on main a5229aca prints files=189 symbols=8020 edges=23968 ambiguous=8947 unresolved=1956 declined=7418 (warm and --no-cache identical). On main 40a1895b (2026-09-11) it read files=166 symbols=5778 edges=17150 ambiguous=7441 unresolved=1658 declined=4803. It read files=153 symbols=5122 edges=14182 ambiguous=5982 unresolved=1598 when the slide was written on 2026-09-06.
+- The src/ census is re-derived, not remembered: `ripwire ./src` on main 255dc199 prints files=195 symbols=8318 edges=25147 ambiguous=9391 unresolved=2008 declined=7742 (warm and --no-cache identical). On main a5229aca (2026-09-30) it read files=189 symbols=8020 edges=23968 ambiguous=8947 unresolved=1956 declined=7418. On main 40a1895b (2026-09-11) it read files=166 symbols=5778 edges=17150 ambiguous=7441 unresolved=1658 declined=4803. It read files=153 symbols=5122 edges=14182 ambiguous=5982 unresolved=1598 when the slide was written on 2026-09-06.
 - declined= is new in 0.6.0 — #136, merge commit d752d953: a call the resolver refused to guess at is now counted instead of vanishing. It belongs on this slide because it is the same contract the other three rules state.
-- The --callers example: `ripwire . --callers=rankGraphTeleport` answered defs="1" count="6" counts_floor="1", with runEval and rankGraph as its first two rows, on main 40a1895b. On main a5229aca: defs="1" count="7" counts_floor="1", with getIndex and rankGraph as its first two rows (a seventh caller, getIndex in src/mcpindex.h, joined since 40a1895b; the slide sample shows the a5229aca answer).</a:t>
+- The --callers example: `ripwire . --callers=rankGraphTeleport` answered defs="1" count="6" counts_floor="1", with runEval and rankGraph as its first two rows, on main 40a1895b. On main a5229aca and again on main 255dc199: defs="1" count="7" counts_floor="1", with getIndex and rankGraph as its first two rows (a seventh caller, getIndex in src/mcpindex.h, joined since 40a1895b; the slide sample shows the answer that still holds on 255dc199).</a:t>
             </a:r>
             <a:endParaRPr lang="en-US" dirty="0"/>
           </a:p>
@@ -3396,7 +3396,7 @@
             <a:r>
               <a:rPr lang="en-US" dirty="0"/>
               <a:t>SOURCES (agent wiring)
-- The nine agents after `wrap`: src/wrap.h's agent table on main a5229aca — claude, codex, cursor, windsurf, gemini, opencode, openclaw, hermes, aider. This line named six until 2026-09-30. On the merged binary, `ripwire wrap --help`: names the same nine (CLI-first: claude, codex, opencode, openclaw, hermes; MCP config: cursor, windsurf, gemini; repo-map: aider).
+- The nine agents after `wrap`: src/wrap.h's agent table on main 255dc199 — claude, codex, cursor, windsurf, gemini, opencode, openclaw, hermes, aider. This line named six until 2026-09-30. On the merged binary, `ripwire wrap --help`: names the same nine (CLI-first: claude, codex, opencode, openclaw, hermes; MCP config: cursor, windsurf, gemini; repo-map: aider).
 - “33 MCP verbs … 17 read verbs … 13 flagship reflexes … 3 span-addressed edit verbs” — README.md, lane/t10-mcp-coverage: “One stdio server, 33 verbs — 17 read, 13 flagship-reflex, 3 span-addressed edit” (rank_by and affected joined the MCP surface, matching the CLI --rank-by / --affected twins).
 - “18 agent skills” — README.md: “skills/ ships eighteen task-shaped skills”; skills/ holds 18 directories.
 - “12 orchestrator loops” — README.md: “prompts/ holds twelve self-contained orchestrator prompts”, and prompts/ holds 12 .md files besides its own README.md. This card said 11 until 2026-09-11; test/readmedriftcheck.sh arm (I1) gates the README against the directory, and the deck now states the same number.</a:t>
@@ -3487,7 +3487,7 @@
           <a:p>
             <a:r>
               <a:rPr lang="en-US" dirty="0"/>
-              <a:t>SOURCES (in the field). README.md on main a5229aca, the collapsed 'Field report' section and its text version — merged: #361 (merge commit 99dc46eb). The README labels it: 'The model's own report of one engagement, on a version before 0.5; not a controlled measurement. Controlled measurements are in docs/EVALS.md.' This slide carries the same three labels: one engagement, the agent's own report, an older version.
+              <a:t>SOURCES (in the field). README.md on main 255dc199, the collapsed 'Field report' section and its text version — merged: #361 (merge commit 99dc46eb). The README labels it: 'The model's own report of one engagement, on a version before 0.5; not a controlled measurement. Controlled measurements are in docs/EVALS.md.' This slide carries the same three labels: one engagement, the agent's own report, an older version.
 WHY NO NUMBERS: the 'Claims you can trust' slide states that no number on this deck lacks a committed instrument behind it. The report's figures (its token-spend estimate, per-call factors, call-site counts, defect counts, agent counts, codebase size) are testimony with no committed instrument, so none is quoted here. The outcomes are.
 - --callers card: the report, 'Two tasks had their direction changed by a single call': a task 'chartered to activate a steering behavior the team believed was in production'; one --callers query 'redirecting the task to the real gap (the data provider that behavior needed had never been wired anywhere)'.
 - --edit-check card: the same paragraph: a task that 'refactored a widely-shared computation'; --edit-check flagged call sites 'a text search had missed' that 'would otherwise have silently diverged from the canonical path the day the feature was enabled'.
@@ -7957,7 +7957,7 @@
                 <a:ea typeface="Courier New" pitchFamily="34" charset="-122"/>
                 <a:cs typeface="Courier New" pitchFamily="34" charset="-120"/>
               </a:rPr>
-              <a:t>upgrade note: parser 129 · cache 27 — a cached index from an earlier build re-indexes once on first use</a:t>
+              <a:t>upgrade note: parser 143 · cache 28 — a cached index from an earlier build re-indexes once on first use</a:t>
             </a:r>
             <a:endParaRPr lang="en-US" sz="1050" dirty="0"/>
           </a:p>
@@ -24794,7 +24794,7 @@
                 <a:ea typeface="Courier New" pitchFamily="34" charset="-122"/>
                 <a:cs typeface="Courier New" pitchFamily="34" charset="-120"/>
               </a:rPr>
-              <a:t>This repository's own src/: files=189 symbols=8020 edges=23968 ambiguous=8947 unresolved=1956 declined=7418.</a:t>
+              <a:t>This repository's own src/: files=195 symbols=8318 edges=25147 ambiguous=9391 unresolved=2008 declined=7742.</a:t>
             </a:r>
             <a:endParaRPr lang="en-US" sz="1000" dirty="0"/>
           </a:p>
@@ -26038,7 +26038,7 @@
                 <a:ea typeface="Arial" pitchFamily="34" charset="-122"/>
                 <a:cs typeface="Arial" pitchFamily="34" charset="-120"/>
               </a:rPr>
-              <a:t>658 gate scripts</a:t>
+              <a:t>664 gate scripts</a:t>
             </a:r>
             <a:endParaRPr lang="en-US" sz="1450" dirty="0"/>
           </a:p>
@@ -26778,7 +26778,7 @@
                 <a:ea typeface="Arial" pitchFamily="34" charset="-122"/>
                 <a:cs typeface="Arial" pitchFamily="34" charset="-120"/>
               </a:rPr>
-              <a:t>658</a:t>
+              <a:t>664</a:t>
             </a:r>
             <a:endParaRPr lang="en-US" sz="4200" dirty="0"/>
           </a:p>
@@ -35203,7 +35203,7 @@
                 <a:ea typeface="Arial" pitchFamily="34" charset="-122"/>
                 <a:cs typeface="Arial" pitchFamily="34" charset="-120"/>
               </a:rPr>
-              <a:t>658 gate scripts</a:t>
+              <a:t>664 gate scripts</a:t>
             </a:r>
             <a:endParaRPr lang="en-US" sz="1200" dirty="0"/>
           </a:p>
@@ -37859,7 +37859,7 @@
                 <a:ea typeface="Courier New" pitchFamily="34" charset="-122"/>
                 <a:cs typeface="Courier New" pitchFamily="34" charset="-120"/>
               </a:rPr>
-              <a:t>--help is generated from the binary's own flag table — 185 long flags; docs/COMMANDS.md carries an entry for every one of them, 162 with a recorded invocation and its output</a:t>
+              <a:t>--help is generated from the binary's own flag table — 185 long flags; docs/COMMANDS.md carries an entry for every one of them, 163 with a recorded invocation and its output</a:t>
             </a:r>
             <a:endParaRPr lang="en-US" sz="1050" dirty="0"/>
           </a:p>

</xml_diff>

<commit_message>
deck: CodeRabbit — name the train-28 build in the 0.6.8 footnote; date the MCP byte figures to 0.6.7
Co-Authored-By: Claude Opus 5.5 <noreply@anthropic.com>
</commit_message>
<xml_diff>
--- a/present/ripwire-showcase.pptx
+++ b/present/ripwire-showcase.pptx
@@ -33822,7 +33822,7 @@
                 <a:ea typeface="Arial" pitchFamily="34" charset="-122"/>
                 <a:cs typeface="Arial" pitchFamily="34" charset="-120"/>
               </a:rPr>
-              <a:t>17 read, 13 flagship reflexes (impact, uses, edit_check, from_trace …), 3 span-addressed edits. --mcp-tools=core lists 8 of them: tools/list is 13,834 B against 46,368 B for all</a:t>
+              <a:t>17 read, 13 flagship reflexes (impact, uses, edit_check, from_trace …), 3 span-addressed edits. --mcp-tools=core lists 8 of them: tools/list is 13,834 B against 46,368 B for all (0.6.7)</a:t>
             </a:r>
             <a:endParaRPr lang="en-US" sz="1150" dirty="0"/>
           </a:p>
@@ -33927,7 +33927,7 @@
                 <a:ea typeface="Arial" pitchFamily="34" charset="-122"/>
                 <a:cs typeface="Arial" pitchFamily="34" charset="-120"/>
               </a:rPr>
-              <a:t>read verbs return signatures and a stable handle; a body is fetched only on request. Each definition is sent once per session: a ten-call session fell 45,463 → 29,679 B</a:t>
+              <a:t>read verbs return signatures and a stable handle; a body is fetched only on request. Each definition is sent once per session: a ten-call session fell 45,463 → 29,679 B (0.6.7)</a:t>
             </a:r>
             <a:endParaRPr lang="en-US" sz="1150" dirty="0"/>
           </a:p>
@@ -43393,7 +43393,7 @@
                 <a:ea typeface="Courier New" pitchFamily="34" charset="-122"/>
                 <a:cs typeface="Courier New" pitchFamily="34" charset="-120"/>
               </a:rPr>
-              <a:t>* 0.6.8 column: its first of four batches; later changes measured on their own questions · v0.6.8 release notes, CHANGELOG [0.6.8]</a:t>
+              <a:t>* 0.6.8: its train-28 build, first of four batches; later changes measured on own questions · v0.6.8 release notes, CHANGELOG [0.6.8]</a:t>
             </a:r>
             <a:endParaRPr lang="en-US" sz="1050" dirty="0"/>
           </a:p>

</xml_diff>